<commit_message>
Unit 3 lessons 3.05 and 3.06 (3.6+3.7 merged) built
Co-Authored-By: Claude Fable 5.1 <noreply@anthropic.com>
</commit_message>
<xml_diff>
--- a/a7/build/out/u3/A7 3.01  Slides.pptx
+++ b/a7/build/out/u3/A7 3.01  Slides.pptx
@@ -7442,7 +7442,7 @@
         <p:spPr>
           <a:xfrm>
             <a:off x="1874519" y="1760220"/>
-            <a:ext cx="913130" cy="457200"/>
+            <a:ext cx="969771" cy="457200"/>
           </a:xfrm>
           <a:prstGeom prst="rect">
             <a:avLst/>
@@ -7484,7 +7484,7 @@
         </p:blipFill>
         <p:spPr>
           <a:xfrm>
-            <a:off x="2650490" y="1784604"/>
+            <a:off x="2707132" y="1784604"/>
             <a:ext cx="688848" cy="408432"/>
           </a:xfrm>
           <a:prstGeom prst="rect">
@@ -7501,7 +7501,7 @@
         <p:spPr>
           <a:xfrm>
             <a:off x="1874519" y="2372868"/>
-            <a:ext cx="6024880" cy="457200"/>
+            <a:ext cx="6285992" cy="457200"/>
           </a:xfrm>
           <a:prstGeom prst="rect">
             <a:avLst/>
@@ -7543,7 +7543,7 @@
         </p:blipFill>
         <p:spPr>
           <a:xfrm>
-            <a:off x="7762240" y="2397252"/>
+            <a:off x="8023352" y="2397252"/>
             <a:ext cx="688848" cy="408432"/>
           </a:xfrm>
           <a:prstGeom prst="rect">
@@ -7559,8 +7559,8 @@
         </p:nvSpPr>
         <p:spPr>
           <a:xfrm>
-            <a:off x="8451088" y="2372868"/>
-            <a:ext cx="328929" cy="457200"/>
+            <a:off x="8712200" y="2372868"/>
+            <a:ext cx="362204" cy="457200"/>
           </a:xfrm>
           <a:prstGeom prst="rect">
             <a:avLst/>
@@ -7595,7 +7595,7 @@
         <p:spPr>
           <a:xfrm>
             <a:off x="1874519" y="2985516"/>
-            <a:ext cx="1935480" cy="457200"/>
+            <a:ext cx="2033015" cy="457200"/>
           </a:xfrm>
           <a:prstGeom prst="rect">
             <a:avLst/>
@@ -7637,7 +7637,7 @@
         </p:blipFill>
         <p:spPr>
           <a:xfrm>
-            <a:off x="3672840" y="3098292"/>
+            <a:off x="3770375" y="3098292"/>
             <a:ext cx="1402080" cy="231648"/>
           </a:xfrm>
           <a:prstGeom prst="rect">
@@ -7654,7 +7654,7 @@
         <p:spPr>
           <a:xfrm>
             <a:off x="1874519" y="3602736"/>
-            <a:ext cx="2373630" cy="457200"/>
+            <a:ext cx="2488692" cy="457200"/>
           </a:xfrm>
           <a:prstGeom prst="rect">
             <a:avLst/>
@@ -7696,7 +7696,7 @@
         </p:blipFill>
         <p:spPr>
           <a:xfrm>
-            <a:off x="4110990" y="3621024"/>
+            <a:off x="4226051" y="3621024"/>
             <a:ext cx="542544" cy="420624"/>
           </a:xfrm>
           <a:prstGeom prst="rect">
@@ -12517,7 +12517,7 @@
         <p:spPr>
           <a:xfrm>
             <a:off x="1874519" y="1760220"/>
-            <a:ext cx="913130" cy="457200"/>
+            <a:ext cx="969771" cy="457200"/>
           </a:xfrm>
           <a:prstGeom prst="rect">
             <a:avLst/>
@@ -12559,7 +12559,7 @@
         </p:blipFill>
         <p:spPr>
           <a:xfrm>
-            <a:off x="2650490" y="1784604"/>
+            <a:off x="2707132" y="1784604"/>
             <a:ext cx="688848" cy="408432"/>
           </a:xfrm>
           <a:prstGeom prst="rect">
@@ -12575,8 +12575,8 @@
         </p:nvSpPr>
         <p:spPr>
           <a:xfrm>
-            <a:off x="3887977" y="1760220"/>
-            <a:ext cx="328929" cy="457200"/>
+            <a:off x="3944619" y="1760220"/>
+            <a:ext cx="379729" cy="457200"/>
           </a:xfrm>
           <a:prstGeom prst="rect">
             <a:avLst/>
@@ -12611,7 +12611,7 @@
         <p:spPr>
           <a:xfrm>
             <a:off x="1874519" y="2372868"/>
-            <a:ext cx="6024880" cy="457200"/>
+            <a:ext cx="6285992" cy="457200"/>
           </a:xfrm>
           <a:prstGeom prst="rect">
             <a:avLst/>
@@ -12653,7 +12653,7 @@
         </p:blipFill>
         <p:spPr>
           <a:xfrm>
-            <a:off x="7762240" y="2397252"/>
+            <a:off x="8023352" y="2397252"/>
             <a:ext cx="688848" cy="408432"/>
           </a:xfrm>
           <a:prstGeom prst="rect">
@@ -12669,8 +12669,8 @@
         </p:nvSpPr>
         <p:spPr>
           <a:xfrm>
-            <a:off x="8451088" y="2372868"/>
-            <a:ext cx="328929" cy="457200"/>
+            <a:off x="8712200" y="2372868"/>
+            <a:ext cx="362204" cy="457200"/>
           </a:xfrm>
           <a:prstGeom prst="rect">
             <a:avLst/>
@@ -12704,8 +12704,8 @@
         </p:nvSpPr>
         <p:spPr>
           <a:xfrm>
-            <a:off x="9191497" y="2372868"/>
-            <a:ext cx="1205230" cy="457200"/>
+            <a:off x="9485884" y="2372868"/>
+            <a:ext cx="1396238" cy="457200"/>
           </a:xfrm>
           <a:prstGeom prst="rect">
             <a:avLst/>
@@ -12740,7 +12740,7 @@
         <p:spPr>
           <a:xfrm>
             <a:off x="1874519" y="2985516"/>
-            <a:ext cx="1935480" cy="457200"/>
+            <a:ext cx="2033015" cy="457200"/>
           </a:xfrm>
           <a:prstGeom prst="rect">
             <a:avLst/>
@@ -12782,7 +12782,7 @@
         </p:blipFill>
         <p:spPr>
           <a:xfrm>
-            <a:off x="3672840" y="3098292"/>
+            <a:off x="3770375" y="3098292"/>
             <a:ext cx="1402080" cy="231648"/>
           </a:xfrm>
           <a:prstGeom prst="rect">
@@ -12798,8 +12798,8 @@
         </p:nvSpPr>
         <p:spPr>
           <a:xfrm>
-            <a:off x="5623559" y="2985516"/>
-            <a:ext cx="913130" cy="457200"/>
+            <a:off x="5721095" y="2985516"/>
+            <a:ext cx="1057402" cy="457200"/>
           </a:xfrm>
           <a:prstGeom prst="rect">
             <a:avLst/>
@@ -12834,7 +12834,7 @@
         <p:spPr>
           <a:xfrm>
             <a:off x="1874519" y="3602736"/>
-            <a:ext cx="2373630" cy="457200"/>
+            <a:ext cx="2488692" cy="457200"/>
           </a:xfrm>
           <a:prstGeom prst="rect">
             <a:avLst/>
@@ -12876,7 +12876,7 @@
         </p:blipFill>
         <p:spPr>
           <a:xfrm>
-            <a:off x="4110990" y="3621024"/>
+            <a:off x="4226051" y="3621024"/>
             <a:ext cx="542544" cy="420624"/>
           </a:xfrm>
           <a:prstGeom prst="rect">
@@ -12900,7 +12900,7 @@
         </p:blipFill>
         <p:spPr>
           <a:xfrm>
-            <a:off x="5202173" y="3621024"/>
+            <a:off x="5317236" y="3621024"/>
             <a:ext cx="118872" cy="426720"/>
           </a:xfrm>
           <a:prstGeom prst="rect">
@@ -13961,8 +13961,8 @@
         </p:nvSpPr>
         <p:spPr>
           <a:xfrm>
-            <a:off x="2671826" y="2746579"/>
-            <a:ext cx="2329180" cy="457200"/>
+            <a:off x="2548635" y="2746579"/>
+            <a:ext cx="2442464" cy="457200"/>
           </a:xfrm>
           <a:prstGeom prst="rect">
             <a:avLst/>
@@ -14004,7 +14004,7 @@
         </p:blipFill>
         <p:spPr>
           <a:xfrm>
-            <a:off x="4863845" y="2769439"/>
+            <a:off x="4853939" y="2769439"/>
             <a:ext cx="1938528" cy="411480"/>
           </a:xfrm>
           <a:prstGeom prst="rect">
@@ -14020,8 +14020,8 @@
         </p:nvSpPr>
         <p:spPr>
           <a:xfrm>
-            <a:off x="6802373" y="2746579"/>
-            <a:ext cx="2824479" cy="457200"/>
+            <a:off x="6792467" y="2746579"/>
+            <a:ext cx="2957576" cy="457200"/>
           </a:xfrm>
           <a:prstGeom prst="rect">
             <a:avLst/>
@@ -14423,8 +14423,8 @@
         </p:nvSpPr>
         <p:spPr>
           <a:xfrm>
-            <a:off x="2671826" y="2655139"/>
-            <a:ext cx="2329180" cy="457200"/>
+            <a:off x="2548635" y="2655139"/>
+            <a:ext cx="2442464" cy="457200"/>
           </a:xfrm>
           <a:prstGeom prst="rect">
             <a:avLst/>
@@ -14466,7 +14466,7 @@
         </p:blipFill>
         <p:spPr>
           <a:xfrm>
-            <a:off x="4863845" y="2677999"/>
+            <a:off x="4853939" y="2677999"/>
             <a:ext cx="1938528" cy="411480"/>
           </a:xfrm>
           <a:prstGeom prst="rect">
@@ -14482,8 +14482,8 @@
         </p:nvSpPr>
         <p:spPr>
           <a:xfrm>
-            <a:off x="6802373" y="2655139"/>
-            <a:ext cx="2824479" cy="457200"/>
+            <a:off x="6792467" y="2655139"/>
+            <a:ext cx="2957576" cy="457200"/>
           </a:xfrm>
           <a:prstGeom prst="rect">
             <a:avLst/>
@@ -15981,7 +15981,7 @@
         </p:blipFill>
         <p:spPr>
           <a:xfrm>
-            <a:off x="3067304" y="4623816"/>
+            <a:off x="3027171" y="4623816"/>
             <a:ext cx="2410968" cy="344424"/>
           </a:xfrm>
           <a:prstGeom prst="rect">
@@ -15997,8 +15997,8 @@
         </p:nvSpPr>
         <p:spPr>
           <a:xfrm>
-            <a:off x="5478272" y="4567428"/>
-            <a:ext cx="1503680" cy="457200"/>
+            <a:off x="5438140" y="4567428"/>
+            <a:ext cx="1583944" cy="457200"/>
           </a:xfrm>
           <a:prstGeom prst="rect">
             <a:avLst/>
@@ -16040,7 +16040,7 @@
         </p:blipFill>
         <p:spPr>
           <a:xfrm>
-            <a:off x="6844792" y="4535424"/>
+            <a:off x="6884924" y="4535424"/>
             <a:ext cx="2249424" cy="521207"/>
           </a:xfrm>
           <a:prstGeom prst="rect">
@@ -16421,7 +16421,7 @@
         </p:blipFill>
         <p:spPr>
           <a:xfrm>
-            <a:off x="1538478" y="3029711"/>
+            <a:off x="1415796" y="3029711"/>
             <a:ext cx="3590544" cy="411480"/>
           </a:xfrm>
           <a:prstGeom prst="rect">
@@ -16437,8 +16437,8 @@
         </p:nvSpPr>
         <p:spPr>
           <a:xfrm>
-            <a:off x="5129022" y="3006852"/>
-            <a:ext cx="5631180" cy="457200"/>
+            <a:off x="5006340" y="3006852"/>
+            <a:ext cx="5876544" cy="457200"/>
           </a:xfrm>
           <a:prstGeom prst="rect">
             <a:avLst/>
@@ -16473,7 +16473,7 @@
         <p:spPr>
           <a:xfrm>
             <a:off x="987552" y="3738371"/>
-            <a:ext cx="3103880" cy="457200"/>
+            <a:ext cx="3598672" cy="457200"/>
           </a:xfrm>
           <a:prstGeom prst="rect">
             <a:avLst/>
@@ -16515,7 +16515,7 @@
         </p:blipFill>
         <p:spPr>
           <a:xfrm>
-            <a:off x="3954272" y="3814572"/>
+            <a:off x="4449064" y="3814572"/>
             <a:ext cx="2313432" cy="304800"/>
           </a:xfrm>
           <a:prstGeom prst="rect">
@@ -16532,7 +16532,7 @@
         <p:spPr>
           <a:xfrm>
             <a:off x="987552" y="4405883"/>
-            <a:ext cx="3103880" cy="457200"/>
+            <a:ext cx="3248152" cy="457200"/>
           </a:xfrm>
           <a:prstGeom prst="rect">
             <a:avLst/>
@@ -16574,7 +16574,7 @@
         </p:blipFill>
         <p:spPr>
           <a:xfrm>
-            <a:off x="3954272" y="4457699"/>
+            <a:off x="4098544" y="4457699"/>
             <a:ext cx="3931920" cy="353568"/>
           </a:xfrm>
           <a:prstGeom prst="rect">
@@ -16913,7 +16913,7 @@
         <p:spPr>
           <a:xfrm>
             <a:off x="987552" y="3049524"/>
-            <a:ext cx="3249929" cy="457200"/>
+            <a:ext cx="3768089" cy="457200"/>
           </a:xfrm>
           <a:prstGeom prst="rect">
             <a:avLst/>
@@ -16955,7 +16955,7 @@
         </p:blipFill>
         <p:spPr>
           <a:xfrm>
-            <a:off x="4100322" y="3102864"/>
+            <a:off x="4618482" y="3102864"/>
             <a:ext cx="2420112" cy="350520"/>
           </a:xfrm>
           <a:prstGeom prst="rect">
@@ -17031,7 +17031,7 @@
         <p:spPr>
           <a:xfrm>
             <a:off x="4724400" y="4448555"/>
-            <a:ext cx="1497330" cy="457200"/>
+            <a:ext cx="1577340" cy="457200"/>
           </a:xfrm>
           <a:prstGeom prst="rect">
             <a:avLst/>
@@ -17073,7 +17073,7 @@
         </p:blipFill>
         <p:spPr>
           <a:xfrm>
-            <a:off x="6084570" y="4471416"/>
+            <a:off x="6164580" y="4471416"/>
             <a:ext cx="2840736" cy="411480"/>
           </a:xfrm>
           <a:prstGeom prst="rect">
@@ -18203,7 +18203,7 @@
         <p:spPr>
           <a:xfrm>
             <a:off x="987552" y="4128515"/>
-            <a:ext cx="2957830" cy="457200"/>
+            <a:ext cx="3429254" cy="457200"/>
           </a:xfrm>
           <a:prstGeom prst="rect">
             <a:avLst/>
@@ -18245,7 +18245,7 @@
         </p:blipFill>
         <p:spPr>
           <a:xfrm>
-            <a:off x="3808222" y="4183380"/>
+            <a:off x="4279646" y="4183380"/>
             <a:ext cx="1837943" cy="347472"/>
           </a:xfrm>
           <a:prstGeom prst="rect">
@@ -18261,8 +18261,8 @@
         </p:nvSpPr>
         <p:spPr>
           <a:xfrm>
-            <a:off x="5646166" y="4128515"/>
-            <a:ext cx="2957830" cy="457200"/>
+            <a:off x="6117590" y="4128515"/>
+            <a:ext cx="3429254" cy="457200"/>
           </a:xfrm>
           <a:prstGeom prst="rect">
             <a:avLst/>
@@ -18304,7 +18304,7 @@
         </p:blipFill>
         <p:spPr>
           <a:xfrm>
-            <a:off x="8466836" y="4186428"/>
+            <a:off x="9409684" y="4186428"/>
             <a:ext cx="972311" cy="341376"/>
           </a:xfrm>
           <a:prstGeom prst="rect">

</xml_diff>

<commit_message>
Unit 3 look-over: every spec re-derived and read whole; slide fractions set display-size, warm-up text measured with real font metrics; source citations tightened; reference-sheet table widened
Co-Authored-By: Claude Fable 5.1 <noreply@anthropic.com>
Claude-Session: https://claude.ai/code/session_015xYWeLUsuszQH6z7ADE9tj
</commit_message>
<xml_diff>
--- a/a7/build/out/u3/A7 3.01  Slides.pptx
+++ b/a7/build/out/u3/A7 3.01  Slides.pptx
@@ -6719,8 +6719,8 @@
         </p:nvSpPr>
         <p:spPr>
           <a:xfrm>
-            <a:off x="1719072" y="2171700"/>
-            <a:ext cx="6563360" cy="457200"/>
+            <a:off x="2145753" y="2171700"/>
+            <a:ext cx="5826384" cy="457200"/>
           </a:xfrm>
           <a:prstGeom prst="rect">
             <a:avLst/>
@@ -6729,7 +6729,7 @@
         </p:spPr>
         <p:txBody>
           <a:bodyPr wrap="none" lIns="45720" rIns="45720" tIns="18288" bIns="18288" anchor="ctr">
-            <a:spAutoFit/>
+            <a:noAutofit/>
           </a:bodyPr>
           <a:lstStyle/>
           <a:p>
@@ -6762,7 +6762,7 @@
         </p:blipFill>
         <p:spPr>
           <a:xfrm>
-            <a:off x="8145272" y="2231136"/>
+            <a:off x="7834978" y="2231136"/>
             <a:ext cx="335280" cy="338328"/>
           </a:xfrm>
           <a:prstGeom prst="rect">
@@ -6778,8 +6778,8 @@
         </p:nvSpPr>
         <p:spPr>
           <a:xfrm>
-            <a:off x="8480552" y="2171700"/>
-            <a:ext cx="2099056" cy="457200"/>
+            <a:off x="8170258" y="2171700"/>
+            <a:ext cx="1982668" cy="457200"/>
           </a:xfrm>
           <a:prstGeom prst="rect">
             <a:avLst/>
@@ -6788,7 +6788,7 @@
         </p:spPr>
         <p:txBody>
           <a:bodyPr wrap="none" lIns="45720" rIns="45720" tIns="18288" bIns="18288" anchor="ctr">
-            <a:spAutoFit/>
+            <a:noAutofit/>
           </a:bodyPr>
           <a:lstStyle/>
           <a:p>
@@ -6813,8 +6813,8 @@
         </p:nvSpPr>
         <p:spPr>
           <a:xfrm>
-            <a:off x="1633219" y="2857500"/>
-            <a:ext cx="1583944" cy="457200"/>
+            <a:off x="2110520" y="2857500"/>
+            <a:ext cx="1485415" cy="457200"/>
           </a:xfrm>
           <a:prstGeom prst="rect">
             <a:avLst/>
@@ -6823,7 +6823,7 @@
         </p:spPr>
         <p:txBody>
           <a:bodyPr wrap="none" lIns="45720" rIns="45720" tIns="18288" bIns="18288" anchor="ctr">
-            <a:spAutoFit/>
+            <a:noAutofit/>
           </a:bodyPr>
           <a:lstStyle/>
           <a:p>
@@ -6856,7 +6856,7 @@
         </p:blipFill>
         <p:spPr>
           <a:xfrm>
-            <a:off x="3080004" y="2918460"/>
+            <a:off x="3458776" y="2918460"/>
             <a:ext cx="335280" cy="335280"/>
           </a:xfrm>
           <a:prstGeom prst="rect">
@@ -6872,8 +6872,8 @@
         </p:nvSpPr>
         <p:spPr>
           <a:xfrm>
-            <a:off x="3415284" y="2857500"/>
-            <a:ext cx="7250176" cy="457200"/>
+            <a:off x="3794056" y="2857500"/>
+            <a:ext cx="6394102" cy="457200"/>
           </a:xfrm>
           <a:prstGeom prst="rect">
             <a:avLst/>
@@ -6882,7 +6882,7 @@
         </p:spPr>
         <p:txBody>
           <a:bodyPr wrap="none" lIns="45720" rIns="45720" tIns="18288" bIns="18288" anchor="ctr">
-            <a:spAutoFit/>
+            <a:noAutofit/>
           </a:bodyPr>
           <a:lstStyle/>
           <a:p>
@@ -7275,8 +7275,8 @@
         </p:nvSpPr>
         <p:spPr>
           <a:xfrm>
-            <a:off x="1719072" y="2080260"/>
-            <a:ext cx="6563360" cy="457200"/>
+            <a:off x="2145753" y="2080260"/>
+            <a:ext cx="5826384" cy="457200"/>
           </a:xfrm>
           <a:prstGeom prst="rect">
             <a:avLst/>
@@ -7285,7 +7285,7 @@
         </p:spPr>
         <p:txBody>
           <a:bodyPr wrap="none" lIns="45720" rIns="45720" tIns="18288" bIns="18288" anchor="ctr">
-            <a:spAutoFit/>
+            <a:noAutofit/>
           </a:bodyPr>
           <a:lstStyle/>
           <a:p>
@@ -7318,7 +7318,7 @@
         </p:blipFill>
         <p:spPr>
           <a:xfrm>
-            <a:off x="8145272" y="2139696"/>
+            <a:off x="7834978" y="2139696"/>
             <a:ext cx="335280" cy="338328"/>
           </a:xfrm>
           <a:prstGeom prst="rect">
@@ -7334,8 +7334,8 @@
         </p:nvSpPr>
         <p:spPr>
           <a:xfrm>
-            <a:off x="8480552" y="2080260"/>
-            <a:ext cx="2099056" cy="457200"/>
+            <a:off x="8170258" y="2080260"/>
+            <a:ext cx="1982668" cy="457200"/>
           </a:xfrm>
           <a:prstGeom prst="rect">
             <a:avLst/>
@@ -7344,7 +7344,7 @@
         </p:spPr>
         <p:txBody>
           <a:bodyPr wrap="none" lIns="45720" rIns="45720" tIns="18288" bIns="18288" anchor="ctr">
-            <a:spAutoFit/>
+            <a:noAutofit/>
           </a:bodyPr>
           <a:lstStyle/>
           <a:p>
@@ -7369,8 +7369,8 @@
         </p:nvSpPr>
         <p:spPr>
           <a:xfrm>
-            <a:off x="1633219" y="2766060"/>
-            <a:ext cx="1583944" cy="457200"/>
+            <a:off x="2110520" y="2766060"/>
+            <a:ext cx="1485415" cy="457200"/>
           </a:xfrm>
           <a:prstGeom prst="rect">
             <a:avLst/>
@@ -7379,7 +7379,7 @@
         </p:spPr>
         <p:txBody>
           <a:bodyPr wrap="none" lIns="45720" rIns="45720" tIns="18288" bIns="18288" anchor="ctr">
-            <a:spAutoFit/>
+            <a:noAutofit/>
           </a:bodyPr>
           <a:lstStyle/>
           <a:p>
@@ -7412,7 +7412,7 @@
         </p:blipFill>
         <p:spPr>
           <a:xfrm>
-            <a:off x="3080004" y="2827019"/>
+            <a:off x="3458776" y="2827019"/>
             <a:ext cx="335280" cy="335280"/>
           </a:xfrm>
           <a:prstGeom prst="rect">
@@ -7428,8 +7428,8 @@
         </p:nvSpPr>
         <p:spPr>
           <a:xfrm>
-            <a:off x="3415284" y="2766060"/>
-            <a:ext cx="7250176" cy="457200"/>
+            <a:off x="3794056" y="2766060"/>
+            <a:ext cx="6394102" cy="457200"/>
           </a:xfrm>
           <a:prstGeom prst="rect">
             <a:avLst/>
@@ -7438,7 +7438,7 @@
         </p:spPr>
         <p:txBody>
           <a:bodyPr wrap="none" lIns="45720" rIns="45720" tIns="18288" bIns="18288" anchor="ctr">
-            <a:spAutoFit/>
+            <a:noAutofit/>
           </a:bodyPr>
           <a:lstStyle/>
           <a:p>
@@ -7895,7 +7895,7 @@
         <p:spPr>
           <a:xfrm>
             <a:off x="1874519" y="1760220"/>
-            <a:ext cx="969771" cy="457200"/>
+            <a:ext cx="720605" cy="457200"/>
           </a:xfrm>
           <a:prstGeom prst="rect">
             <a:avLst/>
@@ -7904,7 +7904,7 @@
         </p:spPr>
         <p:txBody>
           <a:bodyPr wrap="none" lIns="45720" rIns="45720" tIns="18288" bIns="18288" anchor="ctr">
-            <a:spAutoFit/>
+            <a:noAutofit/>
           </a:bodyPr>
           <a:lstStyle/>
           <a:p>
@@ -7937,7 +7937,7 @@
         </p:blipFill>
         <p:spPr>
           <a:xfrm>
-            <a:off x="2707132" y="1784604"/>
+            <a:off x="2457965" y="1784604"/>
             <a:ext cx="688848" cy="408432"/>
           </a:xfrm>
           <a:prstGeom prst="rect">
@@ -7954,7 +7954,7 @@
         <p:spPr>
           <a:xfrm>
             <a:off x="1874519" y="2372868"/>
-            <a:ext cx="6285992" cy="457200"/>
+            <a:ext cx="6163986" cy="457200"/>
           </a:xfrm>
           <a:prstGeom prst="rect">
             <a:avLst/>
@@ -7963,7 +7963,7 @@
         </p:spPr>
         <p:txBody>
           <a:bodyPr wrap="none" lIns="45720" rIns="45720" tIns="18288" bIns="18288" anchor="ctr">
-            <a:spAutoFit/>
+            <a:noAutofit/>
           </a:bodyPr>
           <a:lstStyle/>
           <a:p>
@@ -7996,7 +7996,7 @@
         </p:blipFill>
         <p:spPr>
           <a:xfrm>
-            <a:off x="8023352" y="2397252"/>
+            <a:off x="7901346" y="2397252"/>
             <a:ext cx="688848" cy="408432"/>
           </a:xfrm>
           <a:prstGeom prst="rect">
@@ -8012,8 +8012,8 @@
         </p:nvSpPr>
         <p:spPr>
           <a:xfrm>
-            <a:off x="8712200" y="2372868"/>
-            <a:ext cx="362204" cy="457200"/>
+            <a:off x="8590194" y="2372868"/>
+            <a:ext cx="347771" cy="457200"/>
           </a:xfrm>
           <a:prstGeom prst="rect">
             <a:avLst/>
@@ -8022,7 +8022,7 @@
         </p:spPr>
         <p:txBody>
           <a:bodyPr wrap="none" lIns="45720" rIns="45720" tIns="18288" bIns="18288" anchor="ctr">
-            <a:spAutoFit/>
+            <a:noAutofit/>
           </a:bodyPr>
           <a:lstStyle/>
           <a:p>
@@ -8048,7 +8048,7 @@
         <p:spPr>
           <a:xfrm>
             <a:off x="1874519" y="2985516"/>
-            <a:ext cx="2033015" cy="457200"/>
+            <a:ext cx="1652008" cy="457200"/>
           </a:xfrm>
           <a:prstGeom prst="rect">
             <a:avLst/>
@@ -8057,7 +8057,7 @@
         </p:spPr>
         <p:txBody>
           <a:bodyPr wrap="none" lIns="45720" rIns="45720" tIns="18288" bIns="18288" anchor="ctr">
-            <a:spAutoFit/>
+            <a:noAutofit/>
           </a:bodyPr>
           <a:lstStyle/>
           <a:p>
@@ -8090,7 +8090,7 @@
         </p:blipFill>
         <p:spPr>
           <a:xfrm>
-            <a:off x="3770375" y="3098292"/>
+            <a:off x="3389368" y="3098292"/>
             <a:ext cx="1402080" cy="231648"/>
           </a:xfrm>
           <a:prstGeom prst="rect">
@@ -8106,8 +8106,8 @@
         </p:nvSpPr>
         <p:spPr>
           <a:xfrm>
-            <a:off x="1874519" y="3602736"/>
-            <a:ext cx="2488692" cy="457200"/>
+            <a:off x="1874519" y="3669792"/>
+            <a:ext cx="2190435" cy="457200"/>
           </a:xfrm>
           <a:prstGeom prst="rect">
             <a:avLst/>
@@ -8116,7 +8116,7 @@
         </p:spPr>
         <p:txBody>
           <a:bodyPr wrap="none" lIns="45720" rIns="45720" tIns="18288" bIns="18288" anchor="ctr">
-            <a:spAutoFit/>
+            <a:noAutofit/>
           </a:bodyPr>
           <a:lstStyle/>
           <a:p>
@@ -8135,7 +8135,7 @@
       </p:sp>
       <p:pic>
         <p:nvPicPr>
-          <p:cNvPr id="17" name="Picture 16" descr="dbe118de2b0ec1ed.png"/>
+          <p:cNvPr id="17" name="Picture 16" descr="ec4478436d606ed4.png"/>
           <p:cNvPicPr>
             <a:picLocks noChangeAspect="1"/>
           </p:cNvPicPr>
@@ -8149,8 +8149,8 @@
         </p:blipFill>
         <p:spPr>
           <a:xfrm>
-            <a:off x="4226051" y="3621024"/>
-            <a:ext cx="542544" cy="420624"/>
+            <a:off x="3927795" y="3621024"/>
+            <a:ext cx="637032" cy="554736"/>
           </a:xfrm>
           <a:prstGeom prst="rect">
             <a:avLst/>
@@ -12970,7 +12970,7 @@
         <p:spPr>
           <a:xfrm>
             <a:off x="1874519" y="1760220"/>
-            <a:ext cx="969771" cy="457200"/>
+            <a:ext cx="720605" cy="457200"/>
           </a:xfrm>
           <a:prstGeom prst="rect">
             <a:avLst/>
@@ -12979,7 +12979,7 @@
         </p:spPr>
         <p:txBody>
           <a:bodyPr wrap="none" lIns="45720" rIns="45720" tIns="18288" bIns="18288" anchor="ctr">
-            <a:spAutoFit/>
+            <a:noAutofit/>
           </a:bodyPr>
           <a:lstStyle/>
           <a:p>
@@ -13012,7 +13012,7 @@
         </p:blipFill>
         <p:spPr>
           <a:xfrm>
-            <a:off x="2707132" y="1784604"/>
+            <a:off x="2457965" y="1784604"/>
             <a:ext cx="688848" cy="408432"/>
           </a:xfrm>
           <a:prstGeom prst="rect">
@@ -13028,8 +13028,8 @@
         </p:nvSpPr>
         <p:spPr>
           <a:xfrm>
-            <a:off x="3944619" y="1760220"/>
-            <a:ext cx="379729" cy="457200"/>
+            <a:off x="3695453" y="1760220"/>
+            <a:ext cx="388052" cy="457200"/>
           </a:xfrm>
           <a:prstGeom prst="rect">
             <a:avLst/>
@@ -13038,7 +13038,7 @@
         </p:spPr>
         <p:txBody>
           <a:bodyPr wrap="none" lIns="45720" rIns="45720" tIns="18288" bIns="18288" anchor="ctr">
-            <a:spAutoFit/>
+            <a:noAutofit/>
           </a:bodyPr>
           <a:lstStyle/>
           <a:p>
@@ -13064,7 +13064,7 @@
         <p:spPr>
           <a:xfrm>
             <a:off x="1874519" y="2372868"/>
-            <a:ext cx="6285992" cy="457200"/>
+            <a:ext cx="6163986" cy="457200"/>
           </a:xfrm>
           <a:prstGeom prst="rect">
             <a:avLst/>
@@ -13073,7 +13073,7 @@
         </p:spPr>
         <p:txBody>
           <a:bodyPr wrap="none" lIns="45720" rIns="45720" tIns="18288" bIns="18288" anchor="ctr">
-            <a:spAutoFit/>
+            <a:noAutofit/>
           </a:bodyPr>
           <a:lstStyle/>
           <a:p>
@@ -13106,7 +13106,7 @@
         </p:blipFill>
         <p:spPr>
           <a:xfrm>
-            <a:off x="8023352" y="2397252"/>
+            <a:off x="7901346" y="2397252"/>
             <a:ext cx="688848" cy="408432"/>
           </a:xfrm>
           <a:prstGeom prst="rect">
@@ -13122,8 +13122,8 @@
         </p:nvSpPr>
         <p:spPr>
           <a:xfrm>
-            <a:off x="8712200" y="2372868"/>
-            <a:ext cx="362204" cy="457200"/>
+            <a:off x="8590194" y="2372868"/>
+            <a:ext cx="347771" cy="457200"/>
           </a:xfrm>
           <a:prstGeom prst="rect">
             <a:avLst/>
@@ -13132,7 +13132,7 @@
         </p:spPr>
         <p:txBody>
           <a:bodyPr wrap="none" lIns="45720" rIns="45720" tIns="18288" bIns="18288" anchor="ctr">
-            <a:spAutoFit/>
+            <a:noAutofit/>
           </a:bodyPr>
           <a:lstStyle/>
           <a:p>
@@ -13157,8 +13157,8 @@
         </p:nvSpPr>
         <p:spPr>
           <a:xfrm>
-            <a:off x="9485884" y="2372868"/>
-            <a:ext cx="1396238" cy="457200"/>
+            <a:off x="9349446" y="2372868"/>
+            <a:ext cx="1351321" cy="457200"/>
           </a:xfrm>
           <a:prstGeom prst="rect">
             <a:avLst/>
@@ -13167,7 +13167,7 @@
         </p:spPr>
         <p:txBody>
           <a:bodyPr wrap="none" lIns="45720" rIns="45720" tIns="18288" bIns="18288" anchor="ctr">
-            <a:spAutoFit/>
+            <a:noAutofit/>
           </a:bodyPr>
           <a:lstStyle/>
           <a:p>
@@ -13193,7 +13193,7 @@
         <p:spPr>
           <a:xfrm>
             <a:off x="1874519" y="2985516"/>
-            <a:ext cx="2033015" cy="457200"/>
+            <a:ext cx="1652008" cy="457200"/>
           </a:xfrm>
           <a:prstGeom prst="rect">
             <a:avLst/>
@@ -13202,7 +13202,7 @@
         </p:spPr>
         <p:txBody>
           <a:bodyPr wrap="none" lIns="45720" rIns="45720" tIns="18288" bIns="18288" anchor="ctr">
-            <a:spAutoFit/>
+            <a:noAutofit/>
           </a:bodyPr>
           <a:lstStyle/>
           <a:p>
@@ -13235,7 +13235,7 @@
         </p:blipFill>
         <p:spPr>
           <a:xfrm>
-            <a:off x="3770375" y="3098292"/>
+            <a:off x="3389368" y="3098292"/>
             <a:ext cx="1402080" cy="231648"/>
           </a:xfrm>
           <a:prstGeom prst="rect">
@@ -13251,8 +13251,8 @@
         </p:nvSpPr>
         <p:spPr>
           <a:xfrm>
-            <a:off x="5721095" y="2985516"/>
-            <a:ext cx="1057402" cy="457200"/>
+            <a:off x="5340088" y="2985516"/>
+            <a:ext cx="942623" cy="457200"/>
           </a:xfrm>
           <a:prstGeom prst="rect">
             <a:avLst/>
@@ -13261,7 +13261,7 @@
         </p:spPr>
         <p:txBody>
           <a:bodyPr wrap="none" lIns="45720" rIns="45720" tIns="18288" bIns="18288" anchor="ctr">
-            <a:spAutoFit/>
+            <a:noAutofit/>
           </a:bodyPr>
           <a:lstStyle/>
           <a:p>
@@ -13286,8 +13286,8 @@
         </p:nvSpPr>
         <p:spPr>
           <a:xfrm>
-            <a:off x="1874519" y="3602736"/>
-            <a:ext cx="2488692" cy="457200"/>
+            <a:off x="1874519" y="3669792"/>
+            <a:ext cx="2190435" cy="457200"/>
           </a:xfrm>
           <a:prstGeom prst="rect">
             <a:avLst/>
@@ -13296,7 +13296,7 @@
         </p:spPr>
         <p:txBody>
           <a:bodyPr wrap="none" lIns="45720" rIns="45720" tIns="18288" bIns="18288" anchor="ctr">
-            <a:spAutoFit/>
+            <a:noAutofit/>
           </a:bodyPr>
           <a:lstStyle/>
           <a:p>
@@ -13315,7 +13315,7 @@
       </p:sp>
       <p:pic>
         <p:nvPicPr>
-          <p:cNvPr id="20" name="Picture 19" descr="dbe118de2b0ec1ed.png"/>
+          <p:cNvPr id="20" name="Picture 19" descr="ec4478436d606ed4.png"/>
           <p:cNvPicPr>
             <a:picLocks noChangeAspect="1"/>
           </p:cNvPicPr>
@@ -13329,8 +13329,8 @@
         </p:blipFill>
         <p:spPr>
           <a:xfrm>
-            <a:off x="4226051" y="3621024"/>
-            <a:ext cx="542544" cy="420624"/>
+            <a:off x="3927795" y="3621024"/>
+            <a:ext cx="637032" cy="554736"/>
           </a:xfrm>
           <a:prstGeom prst="rect">
             <a:avLst/>
@@ -13339,7 +13339,7 @@
       </p:pic>
       <p:pic>
         <p:nvPicPr>
-          <p:cNvPr id="21" name="Picture 20" descr="ee89cf951fa0a955.png"/>
+          <p:cNvPr id="21" name="Picture 20" descr="3a92952d92bb77ab.png"/>
           <p:cNvPicPr>
             <a:picLocks noChangeAspect="1"/>
           </p:cNvPicPr>
@@ -13353,8 +13353,8 @@
         </p:blipFill>
         <p:spPr>
           <a:xfrm>
-            <a:off x="5317236" y="3621024"/>
-            <a:ext cx="118872" cy="426720"/>
+            <a:off x="5113467" y="3621024"/>
+            <a:ext cx="170688" cy="557784"/>
           </a:xfrm>
           <a:prstGeom prst="rect">
             <a:avLst/>
@@ -13626,7 +13626,7 @@
       </p:sp>
       <p:pic>
         <p:nvPicPr>
-          <p:cNvPr id="9" name="Picture 8" descr="5874b5ef202c3273.png"/>
+          <p:cNvPr id="9" name="Picture 8" descr="f58654af4b9460c1.png"/>
           <p:cNvPicPr>
             <a:picLocks noChangeAspect="1"/>
           </p:cNvPicPr>
@@ -13640,8 +13640,8 @@
         </p:blipFill>
         <p:spPr>
           <a:xfrm>
-            <a:off x="5059680" y="2194560"/>
-            <a:ext cx="2042160" cy="643128"/>
+            <a:off x="4913376" y="2194560"/>
+            <a:ext cx="2334768" cy="853440"/>
           </a:xfrm>
           <a:prstGeom prst="rect">
             <a:avLst/>
@@ -13983,7 +13983,7 @@
       </p:sp>
       <p:pic>
         <p:nvPicPr>
-          <p:cNvPr id="9" name="Picture 8" descr="5874b5ef202c3273.png"/>
+          <p:cNvPr id="9" name="Picture 8" descr="f58654af4b9460c1.png"/>
           <p:cNvPicPr>
             <a:picLocks noChangeAspect="1"/>
           </p:cNvPicPr>
@@ -13997,8 +13997,8 @@
         </p:blipFill>
         <p:spPr>
           <a:xfrm>
-            <a:off x="5059680" y="2103120"/>
-            <a:ext cx="2042160" cy="643128"/>
+            <a:off x="4913376" y="2103120"/>
+            <a:ext cx="2334768" cy="853440"/>
           </a:xfrm>
           <a:prstGeom prst="rect">
             <a:avLst/>
@@ -14013,7 +14013,7 @@
         </p:nvSpPr>
         <p:spPr>
           <a:xfrm>
-            <a:off x="1828800" y="3020567"/>
+            <a:off x="1828800" y="3230880"/>
             <a:ext cx="8503920" cy="548640"/>
           </a:xfrm>
           <a:prstGeom prst="rect">
@@ -14057,7 +14057,7 @@
         </p:nvSpPr>
         <p:spPr>
           <a:xfrm>
-            <a:off x="4940808" y="4713731"/>
+            <a:off x="4864607" y="4817363"/>
             <a:ext cx="1920240" cy="548640"/>
           </a:xfrm>
           <a:prstGeom prst="rect">
@@ -14086,7 +14086,7 @@
       </p:sp>
       <p:pic>
         <p:nvPicPr>
-          <p:cNvPr id="12" name="Picture 11" descr="b7afcb67ef17a445.png"/>
+          <p:cNvPr id="12" name="Picture 11" descr="08b8d08dca6c5152.png"/>
           <p:cNvPicPr>
             <a:picLocks noChangeAspect="1"/>
           </p:cNvPicPr>
@@ -14100,8 +14100,8 @@
         </p:blipFill>
         <p:spPr>
           <a:xfrm>
-            <a:off x="6861048" y="4663440"/>
-            <a:ext cx="359664" cy="649224"/>
+            <a:off x="6784848" y="4663440"/>
+            <a:ext cx="512064" cy="856488"/>
           </a:xfrm>
           <a:prstGeom prst="rect">
             <a:avLst/>
@@ -14414,8 +14414,8 @@
         </p:nvSpPr>
         <p:spPr>
           <a:xfrm>
-            <a:off x="2548635" y="2746579"/>
-            <a:ext cx="2442464" cy="457200"/>
+            <a:off x="2897912" y="2746579"/>
+            <a:ext cx="2190277" cy="457200"/>
           </a:xfrm>
           <a:prstGeom prst="rect">
             <a:avLst/>
@@ -14424,7 +14424,7 @@
         </p:spPr>
         <p:txBody>
           <a:bodyPr wrap="none" lIns="45720" rIns="45720" tIns="18288" bIns="18288" anchor="ctr">
-            <a:spAutoFit/>
+            <a:noAutofit/>
           </a:bodyPr>
           <a:lstStyle/>
           <a:p>
@@ -14457,7 +14457,7 @@
         </p:blipFill>
         <p:spPr>
           <a:xfrm>
-            <a:off x="4853939" y="2769439"/>
+            <a:off x="4951030" y="2769439"/>
             <a:ext cx="1938528" cy="411480"/>
           </a:xfrm>
           <a:prstGeom prst="rect">
@@ -14473,8 +14473,8 @@
         </p:nvSpPr>
         <p:spPr>
           <a:xfrm>
-            <a:off x="6792467" y="2746579"/>
-            <a:ext cx="2957576" cy="457200"/>
+            <a:off x="6889558" y="2746579"/>
+            <a:ext cx="2511209" cy="457200"/>
           </a:xfrm>
           <a:prstGeom prst="rect">
             <a:avLst/>
@@ -14483,7 +14483,7 @@
         </p:spPr>
         <p:txBody>
           <a:bodyPr wrap="none" lIns="45720" rIns="45720" tIns="18288" bIns="18288" anchor="ctr">
-            <a:spAutoFit/>
+            <a:noAutofit/>
           </a:bodyPr>
           <a:lstStyle/>
           <a:p>
@@ -14876,8 +14876,8 @@
         </p:nvSpPr>
         <p:spPr>
           <a:xfrm>
-            <a:off x="2548635" y="2655139"/>
-            <a:ext cx="2442464" cy="457200"/>
+            <a:off x="2897912" y="2655139"/>
+            <a:ext cx="2190277" cy="457200"/>
           </a:xfrm>
           <a:prstGeom prst="rect">
             <a:avLst/>
@@ -14886,7 +14886,7 @@
         </p:spPr>
         <p:txBody>
           <a:bodyPr wrap="none" lIns="45720" rIns="45720" tIns="18288" bIns="18288" anchor="ctr">
-            <a:spAutoFit/>
+            <a:noAutofit/>
           </a:bodyPr>
           <a:lstStyle/>
           <a:p>
@@ -14919,7 +14919,7 @@
         </p:blipFill>
         <p:spPr>
           <a:xfrm>
-            <a:off x="4853939" y="2677999"/>
+            <a:off x="4951030" y="2677999"/>
             <a:ext cx="1938528" cy="411480"/>
           </a:xfrm>
           <a:prstGeom prst="rect">
@@ -14935,8 +14935,8 @@
         </p:nvSpPr>
         <p:spPr>
           <a:xfrm>
-            <a:off x="6792467" y="2655139"/>
-            <a:ext cx="2957576" cy="457200"/>
+            <a:off x="6889558" y="2655139"/>
+            <a:ext cx="2511209" cy="457200"/>
           </a:xfrm>
           <a:prstGeom prst="rect">
             <a:avLst/>
@@ -14945,7 +14945,7 @@
         </p:spPr>
         <p:txBody>
           <a:bodyPr wrap="none" lIns="45720" rIns="45720" tIns="18288" bIns="18288" anchor="ctr">
-            <a:spAutoFit/>
+            <a:noAutofit/>
           </a:bodyPr>
           <a:lstStyle/>
           <a:p>
@@ -16907,7 +16907,7 @@
         </p:blipFill>
         <p:spPr>
           <a:xfrm>
-            <a:off x="3027171" y="4623816"/>
+            <a:off x="3173976" y="4704588"/>
             <a:ext cx="2410968" cy="344424"/>
           </a:xfrm>
           <a:prstGeom prst="rect">
@@ -16923,8 +16923,8 @@
         </p:nvSpPr>
         <p:spPr>
           <a:xfrm>
-            <a:off x="5438140" y="4567428"/>
-            <a:ext cx="1583944" cy="457200"/>
+            <a:off x="5584944" y="4648200"/>
+            <a:ext cx="988583" cy="457200"/>
           </a:xfrm>
           <a:prstGeom prst="rect">
             <a:avLst/>
@@ -16933,7 +16933,7 @@
         </p:spPr>
         <p:txBody>
           <a:bodyPr wrap="none" lIns="45720" rIns="45720" tIns="18288" bIns="18288" anchor="ctr">
-            <a:spAutoFit/>
+            <a:noAutofit/>
           </a:bodyPr>
           <a:lstStyle/>
           <a:p>
@@ -16952,7 +16952,7 @@
       </p:sp>
       <p:pic>
         <p:nvPicPr>
-          <p:cNvPr id="22" name="Picture 21" descr="58959464df7d592f.png"/>
+          <p:cNvPr id="22" name="Picture 21" descr="2d5d7a819fe41129.png"/>
           <p:cNvPicPr>
             <a:picLocks noChangeAspect="1"/>
           </p:cNvPicPr>
@@ -16966,8 +16966,8 @@
         </p:blipFill>
         <p:spPr>
           <a:xfrm>
-            <a:off x="6884924" y="4535424"/>
-            <a:ext cx="2249424" cy="521207"/>
+            <a:off x="6436367" y="4535424"/>
+            <a:ext cx="2551176" cy="682752"/>
           </a:xfrm>
           <a:prstGeom prst="rect">
             <a:avLst/>
@@ -17347,7 +17347,7 @@
         </p:blipFill>
         <p:spPr>
           <a:xfrm>
-            <a:off x="1415796" y="3029711"/>
+            <a:off x="1675829" y="3029711"/>
             <a:ext cx="3590544" cy="411480"/>
           </a:xfrm>
           <a:prstGeom prst="rect">
@@ -17363,8 +17363,8 @@
         </p:nvSpPr>
         <p:spPr>
           <a:xfrm>
-            <a:off x="5006340" y="3006852"/>
-            <a:ext cx="5876544" cy="457200"/>
+            <a:off x="5266373" y="3006852"/>
+            <a:ext cx="5356477" cy="457200"/>
           </a:xfrm>
           <a:prstGeom prst="rect">
             <a:avLst/>
@@ -17373,7 +17373,7 @@
         </p:spPr>
         <p:txBody>
           <a:bodyPr wrap="none" lIns="45720" rIns="45720" tIns="18288" bIns="18288" anchor="ctr">
-            <a:spAutoFit/>
+            <a:noAutofit/>
           </a:bodyPr>
           <a:lstStyle/>
           <a:p>
@@ -17399,7 +17399,7 @@
         <p:spPr>
           <a:xfrm>
             <a:off x="987552" y="3738371"/>
-            <a:ext cx="3598672" cy="457200"/>
+            <a:ext cx="3419263" cy="457200"/>
           </a:xfrm>
           <a:prstGeom prst="rect">
             <a:avLst/>
@@ -17408,7 +17408,7 @@
         </p:spPr>
         <p:txBody>
           <a:bodyPr wrap="none" lIns="45720" rIns="45720" tIns="18288" bIns="18288" anchor="ctr">
-            <a:spAutoFit/>
+            <a:noAutofit/>
           </a:bodyPr>
           <a:lstStyle/>
           <a:p>
@@ -17441,7 +17441,7 @@
         </p:blipFill>
         <p:spPr>
           <a:xfrm>
-            <a:off x="4449064" y="3814572"/>
+            <a:off x="4269655" y="3814572"/>
             <a:ext cx="2313432" cy="304800"/>
           </a:xfrm>
           <a:prstGeom prst="rect">
@@ -17458,7 +17458,7 @@
         <p:spPr>
           <a:xfrm>
             <a:off x="987552" y="4405883"/>
-            <a:ext cx="3248152" cy="457200"/>
+            <a:ext cx="3088445" cy="457200"/>
           </a:xfrm>
           <a:prstGeom prst="rect">
             <a:avLst/>
@@ -17467,7 +17467,7 @@
         </p:spPr>
         <p:txBody>
           <a:bodyPr wrap="none" lIns="45720" rIns="45720" tIns="18288" bIns="18288" anchor="ctr">
-            <a:spAutoFit/>
+            <a:noAutofit/>
           </a:bodyPr>
           <a:lstStyle/>
           <a:p>
@@ -17500,7 +17500,7 @@
         </p:blipFill>
         <p:spPr>
           <a:xfrm>
-            <a:off x="4098544" y="4457699"/>
+            <a:off x="3938837" y="4457699"/>
             <a:ext cx="3931920" cy="353568"/>
           </a:xfrm>
           <a:prstGeom prst="rect">
@@ -17839,7 +17839,7 @@
         <p:spPr>
           <a:xfrm>
             <a:off x="987552" y="3049524"/>
-            <a:ext cx="3768089" cy="457200"/>
+            <a:ext cx="3530167" cy="457200"/>
           </a:xfrm>
           <a:prstGeom prst="rect">
             <a:avLst/>
@@ -17848,7 +17848,7 @@
         </p:spPr>
         <p:txBody>
           <a:bodyPr wrap="none" lIns="45720" rIns="45720" tIns="18288" bIns="18288" anchor="ctr">
-            <a:spAutoFit/>
+            <a:noAutofit/>
           </a:bodyPr>
           <a:lstStyle/>
           <a:p>
@@ -17881,7 +17881,7 @@
         </p:blipFill>
         <p:spPr>
           <a:xfrm>
-            <a:off x="4618482" y="3102864"/>
+            <a:off x="4380559" y="3102864"/>
             <a:ext cx="2420112" cy="350520"/>
           </a:xfrm>
           <a:prstGeom prst="rect">
@@ -17957,7 +17957,7 @@
         <p:spPr>
           <a:xfrm>
             <a:off x="4724400" y="4448555"/>
-            <a:ext cx="1577340" cy="457200"/>
+            <a:ext cx="1208603" cy="457200"/>
           </a:xfrm>
           <a:prstGeom prst="rect">
             <a:avLst/>
@@ -17966,7 +17966,7 @@
         </p:spPr>
         <p:txBody>
           <a:bodyPr wrap="none" lIns="45720" rIns="45720" tIns="18288" bIns="18288" anchor="ctr">
-            <a:spAutoFit/>
+            <a:noAutofit/>
           </a:bodyPr>
           <a:lstStyle/>
           <a:p>
@@ -17999,7 +17999,7 @@
         </p:blipFill>
         <p:spPr>
           <a:xfrm>
-            <a:off x="6164580" y="4471416"/>
+            <a:off x="5795843" y="4471416"/>
             <a:ext cx="2840736" cy="411480"/>
           </a:xfrm>
           <a:prstGeom prst="rect">
@@ -19129,7 +19129,7 @@
         <p:spPr>
           <a:xfrm>
             <a:off x="987552" y="4128515"/>
-            <a:ext cx="3429254" cy="457200"/>
+            <a:ext cx="3248043" cy="457200"/>
           </a:xfrm>
           <a:prstGeom prst="rect">
             <a:avLst/>
@@ -19138,7 +19138,7 @@
         </p:spPr>
         <p:txBody>
           <a:bodyPr wrap="none" lIns="45720" rIns="45720" tIns="18288" bIns="18288" anchor="ctr">
-            <a:spAutoFit/>
+            <a:noAutofit/>
           </a:bodyPr>
           <a:lstStyle/>
           <a:p>
@@ -19171,7 +19171,7 @@
         </p:blipFill>
         <p:spPr>
           <a:xfrm>
-            <a:off x="4279646" y="4183380"/>
+            <a:off x="4098435" y="4183380"/>
             <a:ext cx="1837943" cy="347472"/>
           </a:xfrm>
           <a:prstGeom prst="rect">
@@ -19187,8 +19187,8 @@
         </p:nvSpPr>
         <p:spPr>
           <a:xfrm>
-            <a:off x="6117590" y="4128515"/>
-            <a:ext cx="3429254" cy="457200"/>
+            <a:off x="5936379" y="4128515"/>
+            <a:ext cx="2486441" cy="457200"/>
           </a:xfrm>
           <a:prstGeom prst="rect">
             <a:avLst/>
@@ -19197,7 +19197,7 @@
         </p:spPr>
         <p:txBody>
           <a:bodyPr wrap="none" lIns="45720" rIns="45720" tIns="18288" bIns="18288" anchor="ctr">
-            <a:spAutoFit/>
+            <a:noAutofit/>
           </a:bodyPr>
           <a:lstStyle/>
           <a:p>
@@ -19230,7 +19230,7 @@
         </p:blipFill>
         <p:spPr>
           <a:xfrm>
-            <a:off x="9409684" y="4186428"/>
+            <a:off x="8285661" y="4186428"/>
             <a:ext cx="972311" cy="341376"/>
           </a:xfrm>
           <a:prstGeom prst="rect">

</xml_diff>

<commit_message>
HTML/KaTeX decks beside every pptx; word boards ask a real question (Units 3 and 4)
Co-Authored-By: Claude Fable 5.1 <noreply@anthropic.com>
Claude-Session: https://claude.ai/code/session_015xYWeLUsuszQH6z7ADE9tj
</commit_message>
<xml_diff>
--- a/a7/build/out/u3/A7 3.01  Slides.pptx
+++ b/a7/build/out/u3/A7 3.01  Slides.pptx
@@ -6720,7 +6720,7 @@
         <p:spPr>
           <a:xfrm>
             <a:off x="1234440" y="1851660"/>
-            <a:ext cx="3271865" cy="457200"/>
+            <a:ext cx="2440586" cy="457200"/>
           </a:xfrm>
           <a:prstGeom prst="rect">
             <a:avLst/>
@@ -6741,7 +6741,7 @@
                 </a:solidFill>
                 <a:latin typeface="Century Schoolbook"/>
               </a:rPr>
-              <a:t>A photo is enlarged  </a:t>
+              <a:t>A rectangle is  </a:t>
             </a:r>
           </a:p>
         </p:txBody>
@@ -6762,7 +6762,7 @@
         </p:blipFill>
         <p:spPr>
           <a:xfrm>
-            <a:off x="4369145" y="1941575"/>
+            <a:off x="3537866" y="1941575"/>
             <a:ext cx="268224" cy="277368"/>
           </a:xfrm>
           <a:prstGeom prst="rect">
@@ -6778,8 +6778,8 @@
         </p:nvSpPr>
         <p:spPr>
           <a:xfrm>
-            <a:off x="4637369" y="1851660"/>
-            <a:ext cx="2255431" cy="457200"/>
+            <a:off x="3806090" y="1851660"/>
+            <a:ext cx="3699967" cy="457200"/>
           </a:xfrm>
           <a:prstGeom prst="rect">
             <a:avLst/>
@@ -6800,7 +6800,7 @@
                 </a:solidFill>
                 <a:latin typeface="Century Schoolbook"/>
               </a:rPr>
-              <a:t>  times, then  </a:t>
+              <a:t>  centimeters long and  </a:t>
             </a:r>
           </a:p>
         </p:txBody>
@@ -6821,7 +6821,7 @@
         </p:blipFill>
         <p:spPr>
           <a:xfrm>
-            <a:off x="6755640" y="1943100"/>
+            <a:off x="7368898" y="1943100"/>
             <a:ext cx="268224" cy="274320"/>
           </a:xfrm>
           <a:prstGeom prst="rect">
@@ -6837,8 +6837,8 @@
         </p:nvSpPr>
         <p:spPr>
           <a:xfrm>
-            <a:off x="7023864" y="1851660"/>
-            <a:ext cx="2149155" cy="457200"/>
+            <a:off x="7637122" y="1851660"/>
+            <a:ext cx="3023764" cy="457200"/>
           </a:xfrm>
           <a:prstGeom prst="rect">
             <a:avLst/>
@@ -6859,7 +6859,7 @@
                 </a:solidFill>
                 <a:latin typeface="Century Schoolbook"/>
               </a:rPr>
-              <a:t>  times more.</a:t>
+              <a:t>  centimeters wide.</a:t>
             </a:r>
           </a:p>
         </p:txBody>
@@ -6872,17 +6872,17 @@
         </p:nvSpPr>
         <p:spPr>
           <a:xfrm>
-            <a:off x="1234440" y="2464308"/>
-            <a:ext cx="1850257" cy="457200"/>
-          </a:xfrm>
-          <a:prstGeom prst="rect">
-            <a:avLst/>
-          </a:prstGeom>
-          <a:noFill/>
-        </p:spPr>
-        <p:txBody>
-          <a:bodyPr wrap="none" lIns="45720" rIns="45720" tIns="18288" bIns="18288" anchor="ctr">
-            <a:noAutofit/>
+            <a:off x="1234440" y="2487168"/>
+            <a:ext cx="10058400" cy="429370"/>
+          </a:xfrm>
+          <a:prstGeom prst="rect">
+            <a:avLst/>
+          </a:prstGeom>
+          <a:noFill/>
+        </p:spPr>
+        <p:txBody>
+          <a:bodyPr wrap="square" lIns="45720" rIns="45720" tIns="18288" bIns="18288" anchor="t">
+            <a:spAutoFit/>
           </a:bodyPr>
           <a:lstStyle/>
           <a:p>
@@ -6894,167 +6894,49 @@
                 </a:solidFill>
                 <a:latin typeface="Century Schoolbook"/>
               </a:rPr>
-              <a:t>In all it is  </a:t>
-            </a:r>
-          </a:p>
-        </p:txBody>
-      </p:sp>
-      <p:pic>
-        <p:nvPicPr>
-          <p:cNvPr id="15" name="Picture 14" descr="b8828baab3c2353b.png"/>
-          <p:cNvPicPr>
-            <a:picLocks noChangeAspect="1"/>
-          </p:cNvPicPr>
-          <p:nvPr/>
-        </p:nvPicPr>
-        <p:blipFill>
-          <a:blip r:embed="rId4"/>
-          <a:stretch>
-            <a:fillRect/>
-          </a:stretch>
-        </p:blipFill>
-        <p:spPr>
-          <a:xfrm>
-            <a:off x="2947537" y="2555748"/>
-            <a:ext cx="758952" cy="274320"/>
-          </a:xfrm>
-          <a:prstGeom prst="rect">
-            <a:avLst/>
-          </a:prstGeom>
-        </p:spPr>
-      </p:pic>
+              <a:t>Its perimeter is 40 centimeters.</a:t>
+            </a:r>
+          </a:p>
+        </p:txBody>
+      </p:sp>
+      <p:sp>
+        <p:nvSpPr>
+          <p:cNvPr id="15" name="TextBox 14"/>
+          <p:cNvSpPr txBox="1"/>
+          <p:nvPr/>
+        </p:nvSpPr>
+        <p:spPr>
+          <a:xfrm>
+            <a:off x="1234440" y="3026266"/>
+            <a:ext cx="10058400" cy="429370"/>
+          </a:xfrm>
+          <a:prstGeom prst="rect">
+            <a:avLst/>
+          </a:prstGeom>
+          <a:noFill/>
+        </p:spPr>
+        <p:txBody>
+          <a:bodyPr wrap="square" lIns="45720" rIns="45720" tIns="18288" bIns="18288" anchor="t">
+            <a:spAutoFit/>
+          </a:bodyPr>
+          <a:lstStyle/>
+          <a:p>
+            <a:pPr algn="l"/>
+            <a:r>
+              <a:rPr sz="2400" b="1" i="0">
+                <a:solidFill>
+                  <a:srgbClr val="1A1A1A"/>
+                </a:solidFill>
+                <a:latin typeface="Century Schoolbook"/>
+              </a:rPr>
+              <a:t>What is the area of the rectangle, in square centimeters?</a:t>
+            </a:r>
+          </a:p>
+        </p:txBody>
+      </p:sp>
       <p:sp>
         <p:nvSpPr>
           <p:cNvPr id="16" name="TextBox 15"/>
-          <p:cNvSpPr txBox="1"/>
-          <p:nvPr/>
-        </p:nvSpPr>
-        <p:spPr>
-          <a:xfrm>
-            <a:off x="3706489" y="2464308"/>
-            <a:ext cx="5894641" cy="457200"/>
-          </a:xfrm>
-          <a:prstGeom prst="rect">
-            <a:avLst/>
-          </a:prstGeom>
-          <a:noFill/>
-        </p:spPr>
-        <p:txBody>
-          <a:bodyPr wrap="none" lIns="45720" rIns="45720" tIns="18288" bIns="18288" anchor="ctr">
-            <a:noAutofit/>
-          </a:bodyPr>
-          <a:lstStyle/>
-          <a:p>
-            <a:pPr algn="l"/>
-            <a:r>
-              <a:rPr sz="2400" b="0" i="0">
-                <a:solidFill>
-                  <a:srgbClr val="1A1A1A"/>
-                </a:solidFill>
-                <a:latin typeface="Century Schoolbook"/>
-              </a:rPr>
-              <a:t>  times bigger. The photo is 9 cm wide.</a:t>
-            </a:r>
-          </a:p>
-        </p:txBody>
-      </p:sp>
-      <p:sp>
-        <p:nvSpPr>
-          <p:cNvPr id="17" name="TextBox 16"/>
-          <p:cNvSpPr txBox="1"/>
-          <p:nvPr/>
-        </p:nvSpPr>
-        <p:spPr>
-          <a:xfrm>
-            <a:off x="1234440" y="3076956"/>
-            <a:ext cx="1316509" cy="457200"/>
-          </a:xfrm>
-          <a:prstGeom prst="rect">
-            <a:avLst/>
-          </a:prstGeom>
-          <a:noFill/>
-        </p:spPr>
-        <p:txBody>
-          <a:bodyPr wrap="none" lIns="45720" rIns="45720" tIns="18288" bIns="18288" anchor="ctr">
-            <a:noAutofit/>
-          </a:bodyPr>
-          <a:lstStyle/>
-          <a:p>
-            <a:pPr algn="l"/>
-            <a:r>
-              <a:rPr sz="2400" b="1" i="0">
-                <a:solidFill>
-                  <a:srgbClr val="1A1A1A"/>
-                </a:solidFill>
-                <a:latin typeface="Century Schoolbook"/>
-              </a:rPr>
-              <a:t>Write  </a:t>
-            </a:r>
-          </a:p>
-        </p:txBody>
-      </p:sp>
-      <p:pic>
-        <p:nvPicPr>
-          <p:cNvPr id="18" name="Picture 17" descr="b8828baab3c2353b.png"/>
-          <p:cNvPicPr>
-            <a:picLocks noChangeAspect="1"/>
-          </p:cNvPicPr>
-          <p:nvPr/>
-        </p:nvPicPr>
-        <p:blipFill>
-          <a:blip r:embed="rId4"/>
-          <a:stretch>
-            <a:fillRect/>
-          </a:stretch>
-        </p:blipFill>
-        <p:spPr>
-          <a:xfrm>
-            <a:off x="2413789" y="3168396"/>
-            <a:ext cx="758952" cy="274320"/>
-          </a:xfrm>
-          <a:prstGeom prst="rect">
-            <a:avLst/>
-          </a:prstGeom>
-        </p:spPr>
-      </p:pic>
-      <p:sp>
-        <p:nvSpPr>
-          <p:cNvPr id="19" name="TextBox 18"/>
-          <p:cNvSpPr txBox="1"/>
-          <p:nvPr/>
-        </p:nvSpPr>
-        <p:spPr>
-          <a:xfrm>
-            <a:off x="3172741" y="3076956"/>
-            <a:ext cx="5959742" cy="457200"/>
-          </a:xfrm>
-          <a:prstGeom prst="rect">
-            <a:avLst/>
-          </a:prstGeom>
-          <a:noFill/>
-        </p:spPr>
-        <p:txBody>
-          <a:bodyPr wrap="none" lIns="45720" rIns="45720" tIns="18288" bIns="18288" anchor="ctr">
-            <a:noAutofit/>
-          </a:bodyPr>
-          <a:lstStyle/>
-          <a:p>
-            <a:pPr algn="l"/>
-            <a:r>
-              <a:rPr sz="2400" b="1" i="0">
-                <a:solidFill>
-                  <a:srgbClr val="1A1A1A"/>
-                </a:solidFill>
-                <a:latin typeface="Century Schoolbook"/>
-              </a:rPr>
-              <a:t>  as one power. Then find its value.</a:t>
-            </a:r>
-          </a:p>
-        </p:txBody>
-      </p:sp>
-      <p:sp>
-        <p:nvSpPr>
-          <p:cNvPr id="20" name="TextBox 19"/>
           <p:cNvSpPr txBox="1"/>
           <p:nvPr/>
         </p:nvSpPr>
@@ -7359,7 +7241,7 @@
         <p:spPr>
           <a:xfrm>
             <a:off x="1234440" y="1851660"/>
-            <a:ext cx="3271865" cy="457200"/>
+            <a:ext cx="2440586" cy="457200"/>
           </a:xfrm>
           <a:prstGeom prst="rect">
             <a:avLst/>
@@ -7380,7 +7262,7 @@
                 </a:solidFill>
                 <a:latin typeface="Century Schoolbook"/>
               </a:rPr>
-              <a:t>A photo is enlarged  </a:t>
+              <a:t>A rectangle is  </a:t>
             </a:r>
           </a:p>
         </p:txBody>
@@ -7401,7 +7283,7 @@
         </p:blipFill>
         <p:spPr>
           <a:xfrm>
-            <a:off x="4369145" y="1943100"/>
+            <a:off x="3537866" y="1943100"/>
             <a:ext cx="274320" cy="274320"/>
           </a:xfrm>
           <a:prstGeom prst="rect">
@@ -7417,8 +7299,8 @@
         </p:nvSpPr>
         <p:spPr>
           <a:xfrm>
-            <a:off x="4643465" y="1851660"/>
-            <a:ext cx="2255431" cy="457200"/>
+            <a:off x="3812186" y="1851660"/>
+            <a:ext cx="3699967" cy="457200"/>
           </a:xfrm>
           <a:prstGeom prst="rect">
             <a:avLst/>
@@ -7439,7 +7321,7 @@
                 </a:solidFill>
                 <a:latin typeface="Century Schoolbook"/>
               </a:rPr>
-              <a:t>  times, then  </a:t>
+              <a:t>  centimeters long and  </a:t>
             </a:r>
           </a:p>
         </p:txBody>
@@ -7460,7 +7342,7 @@
         </p:blipFill>
         <p:spPr>
           <a:xfrm>
-            <a:off x="6761736" y="1943100"/>
+            <a:off x="7374994" y="1943100"/>
             <a:ext cx="271272" cy="274320"/>
           </a:xfrm>
           <a:prstGeom prst="rect">
@@ -7476,8 +7358,8 @@
         </p:nvSpPr>
         <p:spPr>
           <a:xfrm>
-            <a:off x="7033008" y="1851660"/>
-            <a:ext cx="2149155" cy="457200"/>
+            <a:off x="7646266" y="1851660"/>
+            <a:ext cx="3023764" cy="457200"/>
           </a:xfrm>
           <a:prstGeom prst="rect">
             <a:avLst/>
@@ -7498,7 +7380,7 @@
                 </a:solidFill>
                 <a:latin typeface="Century Schoolbook"/>
               </a:rPr>
-              <a:t>  times more.</a:t>
+              <a:t>  centimeters wide.</a:t>
             </a:r>
           </a:p>
         </p:txBody>
@@ -7511,17 +7393,17 @@
         </p:nvSpPr>
         <p:spPr>
           <a:xfrm>
-            <a:off x="1234440" y="2464308"/>
-            <a:ext cx="1850257" cy="457200"/>
-          </a:xfrm>
-          <a:prstGeom prst="rect">
-            <a:avLst/>
-          </a:prstGeom>
-          <a:noFill/>
-        </p:spPr>
-        <p:txBody>
-          <a:bodyPr wrap="none" lIns="45720" rIns="45720" tIns="18288" bIns="18288" anchor="ctr">
-            <a:noAutofit/>
+            <a:off x="1234440" y="2487168"/>
+            <a:ext cx="10058400" cy="429370"/>
+          </a:xfrm>
+          <a:prstGeom prst="rect">
+            <a:avLst/>
+          </a:prstGeom>
+          <a:noFill/>
+        </p:spPr>
+        <p:txBody>
+          <a:bodyPr wrap="square" lIns="45720" rIns="45720" tIns="18288" bIns="18288" anchor="t">
+            <a:spAutoFit/>
           </a:bodyPr>
           <a:lstStyle/>
           <a:p>
@@ -7533,35 +7415,46 @@
                 </a:solidFill>
                 <a:latin typeface="Century Schoolbook"/>
               </a:rPr>
-              <a:t>In all it is  </a:t>
-            </a:r>
-          </a:p>
-        </p:txBody>
-      </p:sp>
-      <p:pic>
-        <p:nvPicPr>
-          <p:cNvPr id="15" name="Picture 14" descr="f05927e7f6eb54a9.png"/>
-          <p:cNvPicPr>
-            <a:picLocks noChangeAspect="1"/>
-          </p:cNvPicPr>
-          <p:nvPr/>
-        </p:nvPicPr>
-        <p:blipFill>
-          <a:blip r:embed="rId4"/>
-          <a:stretch>
-            <a:fillRect/>
-          </a:stretch>
-        </p:blipFill>
-        <p:spPr>
-          <a:xfrm>
-            <a:off x="2947537" y="2555748"/>
-            <a:ext cx="762000" cy="274320"/>
-          </a:xfrm>
-          <a:prstGeom prst="rect">
-            <a:avLst/>
-          </a:prstGeom>
-        </p:spPr>
-      </p:pic>
+              <a:t>Its perimeter is 40 centimeters.</a:t>
+            </a:r>
+          </a:p>
+        </p:txBody>
+      </p:sp>
+      <p:sp>
+        <p:nvSpPr>
+          <p:cNvPr id="15" name="TextBox 14"/>
+          <p:cNvSpPr txBox="1"/>
+          <p:nvPr/>
+        </p:nvSpPr>
+        <p:spPr>
+          <a:xfrm>
+            <a:off x="1234440" y="3026266"/>
+            <a:ext cx="10058400" cy="429370"/>
+          </a:xfrm>
+          <a:prstGeom prst="rect">
+            <a:avLst/>
+          </a:prstGeom>
+          <a:noFill/>
+        </p:spPr>
+        <p:txBody>
+          <a:bodyPr wrap="square" lIns="45720" rIns="45720" tIns="18288" bIns="18288" anchor="t">
+            <a:spAutoFit/>
+          </a:bodyPr>
+          <a:lstStyle/>
+          <a:p>
+            <a:pPr algn="l"/>
+            <a:r>
+              <a:rPr sz="2400" b="1" i="0">
+                <a:solidFill>
+                  <a:srgbClr val="1A1A1A"/>
+                </a:solidFill>
+                <a:latin typeface="Century Schoolbook"/>
+              </a:rPr>
+              <a:t>What is the area of the rectangle, in square centimeters?</a:t>
+            </a:r>
+          </a:p>
+        </p:txBody>
+      </p:sp>
       <p:sp>
         <p:nvSpPr>
           <p:cNvPr id="16" name="TextBox 15"/>
@@ -7570,29 +7463,74 @@
         </p:nvSpPr>
         <p:spPr>
           <a:xfrm>
-            <a:off x="3709537" y="2464308"/>
-            <a:ext cx="5894641" cy="457200"/>
-          </a:xfrm>
-          <a:prstGeom prst="rect">
-            <a:avLst/>
-          </a:prstGeom>
-          <a:noFill/>
-        </p:spPr>
-        <p:txBody>
-          <a:bodyPr wrap="none" lIns="45720" rIns="45720" tIns="18288" bIns="18288" anchor="ctr">
-            <a:noAutofit/>
-          </a:bodyPr>
-          <a:lstStyle/>
-          <a:p>
-            <a:pPr algn="l"/>
+            <a:off x="1828800" y="3656804"/>
+            <a:ext cx="8503920" cy="548640"/>
+          </a:xfrm>
+          <a:prstGeom prst="rect">
+            <a:avLst/>
+          </a:prstGeom>
+          <a:noFill/>
+        </p:spPr>
+        <p:txBody>
+          <a:bodyPr wrap="square" lIns="45720" rIns="45720" tIns="18288" bIns="18288" anchor="t">
+            <a:spAutoFit/>
+          </a:bodyPr>
+          <a:lstStyle/>
+          <a:p>
+            <a:pPr algn="ctr"/>
             <a:r>
               <a:rPr sz="2400" b="0" i="0">
                 <a:solidFill>
-                  <a:srgbClr val="1A1A1A"/>
-                </a:solidFill>
-                <a:latin typeface="Century Schoolbook"/>
-              </a:rPr>
-              <a:t>  times bigger. The photo is 9 cm wide.</a:t>
+                  <a:srgbClr val="6B6B6B"/>
+                </a:solidFill>
+                <a:latin typeface="Century Schoolbook"/>
+              </a:rPr>
+              <a:t>2</a:t>
+            </a:r>
+            <a:r>
+              <a:rPr sz="2400" b="0" i="0" baseline="30000">
+                <a:solidFill>
+                  <a:srgbClr val="6B6B6B"/>
+                </a:solidFill>
+                <a:latin typeface="Century Schoolbook"/>
+              </a:rPr>
+              <a:t>4</a:t>
+            </a:r>
+            <a:r>
+              <a:rPr sz="2400" b="0" i="0">
+                <a:solidFill>
+                  <a:srgbClr val="6B6B6B"/>
+                </a:solidFill>
+                <a:latin typeface="Century Schoolbook"/>
+              </a:rPr>
+              <a:t> · 2</a:t>
+            </a:r>
+            <a:r>
+              <a:rPr sz="2400" b="0" i="0" baseline="30000">
+                <a:solidFill>
+                  <a:srgbClr val="6B6B6B"/>
+                </a:solidFill>
+                <a:latin typeface="Century Schoolbook"/>
+              </a:rPr>
+              <a:t>2</a:t>
+            </a:r>
+            <a:r>
+              <a:rPr sz="2400" b="0" i="0">
+                <a:solidFill>
+                  <a:srgbClr val="6B6B6B"/>
+                </a:solidFill>
+                <a:latin typeface="Century Schoolbook"/>
+              </a:rPr>
+              <a:t> = 2</a:t>
+            </a:r>
+            <a:r>
+              <a:rPr sz="2400" b="0" i="0" baseline="30000">
+                <a:solidFill>
+                  <a:srgbClr val="6B6B6B"/>
+                </a:solidFill>
+                <a:latin typeface="Century Schoolbook"/>
+              </a:rPr>
+              <a:t>6</a:t>
             </a:r>
           </a:p>
         </p:txBody>
@@ -7600,180 +7538,6 @@
       <p:sp>
         <p:nvSpPr>
           <p:cNvPr id="17" name="TextBox 16"/>
-          <p:cNvSpPr txBox="1"/>
-          <p:nvPr/>
-        </p:nvSpPr>
-        <p:spPr>
-          <a:xfrm>
-            <a:off x="1234440" y="3076956"/>
-            <a:ext cx="1316509" cy="457200"/>
-          </a:xfrm>
-          <a:prstGeom prst="rect">
-            <a:avLst/>
-          </a:prstGeom>
-          <a:noFill/>
-        </p:spPr>
-        <p:txBody>
-          <a:bodyPr wrap="none" lIns="45720" rIns="45720" tIns="18288" bIns="18288" anchor="ctr">
-            <a:noAutofit/>
-          </a:bodyPr>
-          <a:lstStyle/>
-          <a:p>
-            <a:pPr algn="l"/>
-            <a:r>
-              <a:rPr sz="2400" b="1" i="0">
-                <a:solidFill>
-                  <a:srgbClr val="1A1A1A"/>
-                </a:solidFill>
-                <a:latin typeface="Century Schoolbook"/>
-              </a:rPr>
-              <a:t>Write  </a:t>
-            </a:r>
-          </a:p>
-        </p:txBody>
-      </p:sp>
-      <p:pic>
-        <p:nvPicPr>
-          <p:cNvPr id="18" name="Picture 17" descr="f05927e7f6eb54a9.png"/>
-          <p:cNvPicPr>
-            <a:picLocks noChangeAspect="1"/>
-          </p:cNvPicPr>
-          <p:nvPr/>
-        </p:nvPicPr>
-        <p:blipFill>
-          <a:blip r:embed="rId4"/>
-          <a:stretch>
-            <a:fillRect/>
-          </a:stretch>
-        </p:blipFill>
-        <p:spPr>
-          <a:xfrm>
-            <a:off x="2413789" y="3168396"/>
-            <a:ext cx="762000" cy="274320"/>
-          </a:xfrm>
-          <a:prstGeom prst="rect">
-            <a:avLst/>
-          </a:prstGeom>
-        </p:spPr>
-      </p:pic>
-      <p:sp>
-        <p:nvSpPr>
-          <p:cNvPr id="19" name="TextBox 18"/>
-          <p:cNvSpPr txBox="1"/>
-          <p:nvPr/>
-        </p:nvSpPr>
-        <p:spPr>
-          <a:xfrm>
-            <a:off x="3175789" y="3076956"/>
-            <a:ext cx="5959742" cy="457200"/>
-          </a:xfrm>
-          <a:prstGeom prst="rect">
-            <a:avLst/>
-          </a:prstGeom>
-          <a:noFill/>
-        </p:spPr>
-        <p:txBody>
-          <a:bodyPr wrap="none" lIns="45720" rIns="45720" tIns="18288" bIns="18288" anchor="ctr">
-            <a:noAutofit/>
-          </a:bodyPr>
-          <a:lstStyle/>
-          <a:p>
-            <a:pPr algn="l"/>
-            <a:r>
-              <a:rPr sz="2400" b="1" i="0">
-                <a:solidFill>
-                  <a:srgbClr val="1A1A1A"/>
-                </a:solidFill>
-                <a:latin typeface="Century Schoolbook"/>
-              </a:rPr>
-              <a:t>  as one power. Then find its value.</a:t>
-            </a:r>
-          </a:p>
-        </p:txBody>
-      </p:sp>
-      <p:sp>
-        <p:nvSpPr>
-          <p:cNvPr id="20" name="TextBox 19"/>
-          <p:cNvSpPr txBox="1"/>
-          <p:nvPr/>
-        </p:nvSpPr>
-        <p:spPr>
-          <a:xfrm>
-            <a:off x="1828800" y="3803904"/>
-            <a:ext cx="8503920" cy="548640"/>
-          </a:xfrm>
-          <a:prstGeom prst="rect">
-            <a:avLst/>
-          </a:prstGeom>
-          <a:noFill/>
-        </p:spPr>
-        <p:txBody>
-          <a:bodyPr wrap="square" lIns="45720" rIns="45720" tIns="18288" bIns="18288" anchor="t">
-            <a:spAutoFit/>
-          </a:bodyPr>
-          <a:lstStyle/>
-          <a:p>
-            <a:pPr algn="ctr"/>
-            <a:r>
-              <a:rPr sz="2400" b="0" i="0">
-                <a:solidFill>
-                  <a:srgbClr val="6B6B6B"/>
-                </a:solidFill>
-                <a:latin typeface="Century Schoolbook"/>
-              </a:rPr>
-              <a:t>2</a:t>
-            </a:r>
-            <a:r>
-              <a:rPr sz="2400" b="0" i="0" baseline="30000">
-                <a:solidFill>
-                  <a:srgbClr val="6B6B6B"/>
-                </a:solidFill>
-                <a:latin typeface="Century Schoolbook"/>
-              </a:rPr>
-              <a:t>4</a:t>
-            </a:r>
-            <a:r>
-              <a:rPr sz="2400" b="0" i="0">
-                <a:solidFill>
-                  <a:srgbClr val="6B6B6B"/>
-                </a:solidFill>
-                <a:latin typeface="Century Schoolbook"/>
-              </a:rPr>
-              <a:t> · 2</a:t>
-            </a:r>
-            <a:r>
-              <a:rPr sz="2400" b="0" i="0" baseline="30000">
-                <a:solidFill>
-                  <a:srgbClr val="6B6B6B"/>
-                </a:solidFill>
-                <a:latin typeface="Century Schoolbook"/>
-              </a:rPr>
-              <a:t>2</a:t>
-            </a:r>
-            <a:r>
-              <a:rPr sz="2400" b="0" i="0">
-                <a:solidFill>
-                  <a:srgbClr val="6B6B6B"/>
-                </a:solidFill>
-                <a:latin typeface="Century Schoolbook"/>
-              </a:rPr>
-              <a:t> = 2</a:t>
-            </a:r>
-            <a:r>
-              <a:rPr sz="2400" b="0" i="0" baseline="30000">
-                <a:solidFill>
-                  <a:srgbClr val="6B6B6B"/>
-                </a:solidFill>
-                <a:latin typeface="Century Schoolbook"/>
-              </a:rPr>
-              <a:t>6</a:t>
-            </a:r>
-          </a:p>
-        </p:txBody>
-      </p:sp>
-      <p:sp>
-        <p:nvSpPr>
-          <p:cNvPr id="21" name="TextBox 20"/>
           <p:cNvSpPr txBox="1"/>
           <p:nvPr/>
         </p:nvSpPr>
@@ -7819,7 +7583,7 @@
                 </a:solidFill>
                 <a:latin typeface="Century Schoolbook"/>
               </a:rPr>
-              <a:t> = 64</a:t>
+              <a:t> = 64 square centimeters</a:t>
             </a:r>
           </a:p>
         </p:txBody>

</xml_diff>